<commit_message>
chore: add .gitignore entry to ignore lock files
</commit_message>
<xml_diff>
--- a/the_captcha_game.pptx
+++ b/the_captcha_game.pptx
@@ -6,6 +6,13 @@
   </p:sldMasterIdLst>
   <p:sldIdLst>
     <p:sldId id="256" r:id="rId2"/>
+    <p:sldId id="257" r:id="rId3"/>
+    <p:sldId id="258" r:id="rId4"/>
+    <p:sldId id="259" r:id="rId5"/>
+    <p:sldId id="260" r:id="rId6"/>
+    <p:sldId id="261" r:id="rId7"/>
+    <p:sldId id="262" r:id="rId8"/>
+    <p:sldId id="263" r:id="rId9"/>
   </p:sldIdLst>
   <p:sldSz cx="12192000" cy="6858000"/>
   <p:notesSz cx="6858000" cy="9144000"/>
@@ -5302,6 +5309,597 @@
 </p:sld>
 </file>
 
+<file path=ppt/slides/slide2.xml><?xml version="1.0" encoding="utf-8"?>
+<p:sld xmlns:a="http://schemas.openxmlformats.org/drawingml/2006/main" xmlns:r="http://schemas.openxmlformats.org/officeDocument/2006/relationships" xmlns:p="http://schemas.openxmlformats.org/presentationml/2006/main">
+  <p:cSld>
+    <p:spTree>
+      <p:nvGrpSpPr>
+        <p:cNvPr id="1" name=""/>
+        <p:cNvGrpSpPr/>
+        <p:nvPr/>
+      </p:nvGrpSpPr>
+      <p:grpSpPr>
+        <a:xfrm>
+          <a:off x="0" y="0"/>
+          <a:ext cx="0" cy="0"/>
+          <a:chOff x="0" y="0"/>
+          <a:chExt cx="0" cy="0"/>
+        </a:xfrm>
+      </p:grpSpPr>
+      <p:sp>
+        <p:nvSpPr>
+          <p:cNvPr id="2" name="Título 1">
+            <a:extLst>
+              <a:ext uri="{FF2B5EF4-FFF2-40B4-BE49-F238E27FC236}">
+                <a16:creationId xmlns:a16="http://schemas.microsoft.com/office/drawing/2014/main" id="{9D6267E0-1666-FE88-F39E-3CE7F31753FB}"/>
+              </a:ext>
+            </a:extLst>
+          </p:cNvPr>
+          <p:cNvSpPr>
+            <a:spLocks noGrp="1"/>
+          </p:cNvSpPr>
+          <p:nvPr>
+            <p:ph type="title"/>
+          </p:nvPr>
+        </p:nvSpPr>
+        <p:spPr/>
+        <p:txBody>
+          <a:bodyPr/>
+          <a:lstStyle/>
+          <a:p>
+            <a:r>
+              <a:rPr lang="es-ES" dirty="0"/>
+              <a:t>h1</a:t>
+            </a:r>
+            <a:endParaRPr lang="es-EC" dirty="0"/>
+          </a:p>
+        </p:txBody>
+      </p:sp>
+      <p:sp>
+        <p:nvSpPr>
+          <p:cNvPr id="3" name="Marcador de contenido 2">
+            <a:extLst>
+              <a:ext uri="{FF2B5EF4-FFF2-40B4-BE49-F238E27FC236}">
+                <a16:creationId xmlns:a16="http://schemas.microsoft.com/office/drawing/2014/main" id="{ABA7393D-0ED3-E20F-B86F-A5F2ED20490F}"/>
+              </a:ext>
+            </a:extLst>
+          </p:cNvPr>
+          <p:cNvSpPr>
+            <a:spLocks noGrp="1"/>
+          </p:cNvSpPr>
+          <p:nvPr>
+            <p:ph idx="1"/>
+          </p:nvPr>
+        </p:nvSpPr>
+        <p:spPr/>
+        <p:txBody>
+          <a:bodyPr/>
+          <a:lstStyle/>
+          <a:p>
+            <a:endParaRPr lang="es-EC"/>
+          </a:p>
+        </p:txBody>
+      </p:sp>
+    </p:spTree>
+    <p:extLst>
+      <p:ext uri="{BB962C8B-B14F-4D97-AF65-F5344CB8AC3E}">
+        <p14:creationId xmlns:p14="http://schemas.microsoft.com/office/powerpoint/2010/main" val="333073607"/>
+      </p:ext>
+    </p:extLst>
+  </p:cSld>
+  <p:clrMapOvr>
+    <a:masterClrMapping/>
+  </p:clrMapOvr>
+</p:sld>
+</file>
+
+<file path=ppt/slides/slide3.xml><?xml version="1.0" encoding="utf-8"?>
+<p:sld xmlns:a="http://schemas.openxmlformats.org/drawingml/2006/main" xmlns:r="http://schemas.openxmlformats.org/officeDocument/2006/relationships" xmlns:p="http://schemas.openxmlformats.org/presentationml/2006/main">
+  <p:cSld>
+    <p:spTree>
+      <p:nvGrpSpPr>
+        <p:cNvPr id="1" name=""/>
+        <p:cNvGrpSpPr/>
+        <p:nvPr/>
+      </p:nvGrpSpPr>
+      <p:grpSpPr>
+        <a:xfrm>
+          <a:off x="0" y="0"/>
+          <a:ext cx="0" cy="0"/>
+          <a:chOff x="0" y="0"/>
+          <a:chExt cx="0" cy="0"/>
+        </a:xfrm>
+      </p:grpSpPr>
+      <p:sp>
+        <p:nvSpPr>
+          <p:cNvPr id="2" name="Título 1">
+            <a:extLst>
+              <a:ext uri="{FF2B5EF4-FFF2-40B4-BE49-F238E27FC236}">
+                <a16:creationId xmlns:a16="http://schemas.microsoft.com/office/drawing/2014/main" id="{2E19BE9B-4F51-DB67-3E6C-15DB10995959}"/>
+              </a:ext>
+            </a:extLst>
+          </p:cNvPr>
+          <p:cNvSpPr>
+            <a:spLocks noGrp="1"/>
+          </p:cNvSpPr>
+          <p:nvPr>
+            <p:ph type="title"/>
+          </p:nvPr>
+        </p:nvSpPr>
+        <p:spPr/>
+        <p:txBody>
+          <a:bodyPr/>
+          <a:lstStyle/>
+          <a:p>
+            <a:r>
+              <a:rPr lang="es-ES" dirty="0"/>
+              <a:t>H2</a:t>
+            </a:r>
+            <a:br>
+              <a:rPr lang="es-ES" dirty="0"/>
+            </a:br>
+            <a:endParaRPr lang="es-EC" dirty="0"/>
+          </a:p>
+        </p:txBody>
+      </p:sp>
+      <p:sp>
+        <p:nvSpPr>
+          <p:cNvPr id="3" name="Marcador de contenido 2">
+            <a:extLst>
+              <a:ext uri="{FF2B5EF4-FFF2-40B4-BE49-F238E27FC236}">
+                <a16:creationId xmlns:a16="http://schemas.microsoft.com/office/drawing/2014/main" id="{7C3D4543-E5BF-6330-0003-7C5B9A966EED}"/>
+              </a:ext>
+            </a:extLst>
+          </p:cNvPr>
+          <p:cNvSpPr>
+            <a:spLocks noGrp="1"/>
+          </p:cNvSpPr>
+          <p:nvPr>
+            <p:ph idx="1"/>
+          </p:nvPr>
+        </p:nvSpPr>
+        <p:spPr/>
+        <p:txBody>
+          <a:bodyPr/>
+          <a:lstStyle/>
+          <a:p>
+            <a:endParaRPr lang="es-EC"/>
+          </a:p>
+        </p:txBody>
+      </p:sp>
+    </p:spTree>
+    <p:extLst>
+      <p:ext uri="{BB962C8B-B14F-4D97-AF65-F5344CB8AC3E}">
+        <p14:creationId xmlns:p14="http://schemas.microsoft.com/office/powerpoint/2010/main" val="29584803"/>
+      </p:ext>
+    </p:extLst>
+  </p:cSld>
+  <p:clrMapOvr>
+    <a:masterClrMapping/>
+  </p:clrMapOvr>
+</p:sld>
+</file>
+
+<file path=ppt/slides/slide4.xml><?xml version="1.0" encoding="utf-8"?>
+<p:sld xmlns:a="http://schemas.openxmlformats.org/drawingml/2006/main" xmlns:r="http://schemas.openxmlformats.org/officeDocument/2006/relationships" xmlns:p="http://schemas.openxmlformats.org/presentationml/2006/main">
+  <p:cSld>
+    <p:spTree>
+      <p:nvGrpSpPr>
+        <p:cNvPr id="1" name=""/>
+        <p:cNvGrpSpPr/>
+        <p:nvPr/>
+      </p:nvGrpSpPr>
+      <p:grpSpPr>
+        <a:xfrm>
+          <a:off x="0" y="0"/>
+          <a:ext cx="0" cy="0"/>
+          <a:chOff x="0" y="0"/>
+          <a:chExt cx="0" cy="0"/>
+        </a:xfrm>
+      </p:grpSpPr>
+      <p:sp>
+        <p:nvSpPr>
+          <p:cNvPr id="2" name="Título 1">
+            <a:extLst>
+              <a:ext uri="{FF2B5EF4-FFF2-40B4-BE49-F238E27FC236}">
+                <a16:creationId xmlns:a16="http://schemas.microsoft.com/office/drawing/2014/main" id="{D2DBCAFB-7AA6-7558-1DB6-5737581470EA}"/>
+              </a:ext>
+            </a:extLst>
+          </p:cNvPr>
+          <p:cNvSpPr>
+            <a:spLocks noGrp="1"/>
+          </p:cNvSpPr>
+          <p:nvPr>
+            <p:ph type="title"/>
+          </p:nvPr>
+        </p:nvSpPr>
+        <p:spPr/>
+        <p:txBody>
+          <a:bodyPr/>
+          <a:lstStyle/>
+          <a:p>
+            <a:r>
+              <a:rPr lang="es-ES" dirty="0"/>
+              <a:t>h3</a:t>
+            </a:r>
+            <a:endParaRPr lang="es-EC" dirty="0"/>
+          </a:p>
+        </p:txBody>
+      </p:sp>
+      <p:sp>
+        <p:nvSpPr>
+          <p:cNvPr id="3" name="Marcador de contenido 2">
+            <a:extLst>
+              <a:ext uri="{FF2B5EF4-FFF2-40B4-BE49-F238E27FC236}">
+                <a16:creationId xmlns:a16="http://schemas.microsoft.com/office/drawing/2014/main" id="{65FD0FE9-A4B0-34C8-B749-C1DFC6569AE6}"/>
+              </a:ext>
+            </a:extLst>
+          </p:cNvPr>
+          <p:cNvSpPr>
+            <a:spLocks noGrp="1"/>
+          </p:cNvSpPr>
+          <p:nvPr>
+            <p:ph idx="1"/>
+          </p:nvPr>
+        </p:nvSpPr>
+        <p:spPr/>
+        <p:txBody>
+          <a:bodyPr/>
+          <a:lstStyle/>
+          <a:p>
+            <a:endParaRPr lang="es-EC"/>
+          </a:p>
+        </p:txBody>
+      </p:sp>
+    </p:spTree>
+    <p:extLst>
+      <p:ext uri="{BB962C8B-B14F-4D97-AF65-F5344CB8AC3E}">
+        <p14:creationId xmlns:p14="http://schemas.microsoft.com/office/powerpoint/2010/main" val="3283918707"/>
+      </p:ext>
+    </p:extLst>
+  </p:cSld>
+  <p:clrMapOvr>
+    <a:masterClrMapping/>
+  </p:clrMapOvr>
+</p:sld>
+</file>
+
+<file path=ppt/slides/slide5.xml><?xml version="1.0" encoding="utf-8"?>
+<p:sld xmlns:a="http://schemas.openxmlformats.org/drawingml/2006/main" xmlns:r="http://schemas.openxmlformats.org/officeDocument/2006/relationships" xmlns:p="http://schemas.openxmlformats.org/presentationml/2006/main">
+  <p:cSld>
+    <p:spTree>
+      <p:nvGrpSpPr>
+        <p:cNvPr id="1" name=""/>
+        <p:cNvGrpSpPr/>
+        <p:nvPr/>
+      </p:nvGrpSpPr>
+      <p:grpSpPr>
+        <a:xfrm>
+          <a:off x="0" y="0"/>
+          <a:ext cx="0" cy="0"/>
+          <a:chOff x="0" y="0"/>
+          <a:chExt cx="0" cy="0"/>
+        </a:xfrm>
+      </p:grpSpPr>
+      <p:sp>
+        <p:nvSpPr>
+          <p:cNvPr id="2" name="Título 1">
+            <a:extLst>
+              <a:ext uri="{FF2B5EF4-FFF2-40B4-BE49-F238E27FC236}">
+                <a16:creationId xmlns:a16="http://schemas.microsoft.com/office/drawing/2014/main" id="{BA7BC7EC-85AE-16FC-AB04-8A6F1F8CDA67}"/>
+              </a:ext>
+            </a:extLst>
+          </p:cNvPr>
+          <p:cNvSpPr>
+            <a:spLocks noGrp="1"/>
+          </p:cNvSpPr>
+          <p:nvPr>
+            <p:ph type="title"/>
+          </p:nvPr>
+        </p:nvSpPr>
+        <p:spPr/>
+        <p:txBody>
+          <a:bodyPr/>
+          <a:lstStyle/>
+          <a:p>
+            <a:r>
+              <a:rPr lang="es-ES" dirty="0"/>
+              <a:t>Bs captcha</a:t>
+            </a:r>
+            <a:endParaRPr lang="es-EC" dirty="0"/>
+          </a:p>
+        </p:txBody>
+      </p:sp>
+      <p:sp>
+        <p:nvSpPr>
+          <p:cNvPr id="3" name="Marcador de contenido 2">
+            <a:extLst>
+              <a:ext uri="{FF2B5EF4-FFF2-40B4-BE49-F238E27FC236}">
+                <a16:creationId xmlns:a16="http://schemas.microsoft.com/office/drawing/2014/main" id="{6B4EB59F-BA08-49B6-1D05-C6FC041614B7}"/>
+              </a:ext>
+            </a:extLst>
+          </p:cNvPr>
+          <p:cNvSpPr>
+            <a:spLocks noGrp="1"/>
+          </p:cNvSpPr>
+          <p:nvPr>
+            <p:ph idx="1"/>
+          </p:nvPr>
+        </p:nvSpPr>
+        <p:spPr/>
+        <p:txBody>
+          <a:bodyPr/>
+          <a:lstStyle/>
+          <a:p>
+            <a:endParaRPr lang="es-EC"/>
+          </a:p>
+        </p:txBody>
+      </p:sp>
+    </p:spTree>
+    <p:extLst>
+      <p:ext uri="{BB962C8B-B14F-4D97-AF65-F5344CB8AC3E}">
+        <p14:creationId xmlns:p14="http://schemas.microsoft.com/office/powerpoint/2010/main" val="2614673615"/>
+      </p:ext>
+    </p:extLst>
+  </p:cSld>
+  <p:clrMapOvr>
+    <a:masterClrMapping/>
+  </p:clrMapOvr>
+</p:sld>
+</file>
+
+<file path=ppt/slides/slide6.xml><?xml version="1.0" encoding="utf-8"?>
+<p:sld xmlns:a="http://schemas.openxmlformats.org/drawingml/2006/main" xmlns:r="http://schemas.openxmlformats.org/officeDocument/2006/relationships" xmlns:p="http://schemas.openxmlformats.org/presentationml/2006/main">
+  <p:cSld>
+    <p:spTree>
+      <p:nvGrpSpPr>
+        <p:cNvPr id="1" name=""/>
+        <p:cNvGrpSpPr/>
+        <p:nvPr/>
+      </p:nvGrpSpPr>
+      <p:grpSpPr>
+        <a:xfrm>
+          <a:off x="0" y="0"/>
+          <a:ext cx="0" cy="0"/>
+          <a:chOff x="0" y="0"/>
+          <a:chExt cx="0" cy="0"/>
+        </a:xfrm>
+      </p:grpSpPr>
+      <p:sp>
+        <p:nvSpPr>
+          <p:cNvPr id="2" name="Título 1">
+            <a:extLst>
+              <a:ext uri="{FF2B5EF4-FFF2-40B4-BE49-F238E27FC236}">
+                <a16:creationId xmlns:a16="http://schemas.microsoft.com/office/drawing/2014/main" id="{062033EF-F26A-46DB-9B9E-C550AFCB3BE4}"/>
+              </a:ext>
+            </a:extLst>
+          </p:cNvPr>
+          <p:cNvSpPr>
+            <a:spLocks noGrp="1"/>
+          </p:cNvSpPr>
+          <p:nvPr>
+            <p:ph type="title"/>
+          </p:nvPr>
+        </p:nvSpPr>
+        <p:spPr/>
+        <p:txBody>
+          <a:bodyPr/>
+          <a:lstStyle/>
+          <a:p>
+            <a:r>
+              <a:rPr lang="es-ES" dirty="0"/>
+              <a:t>c1</a:t>
+            </a:r>
+            <a:endParaRPr lang="es-EC" dirty="0"/>
+          </a:p>
+        </p:txBody>
+      </p:sp>
+      <p:sp>
+        <p:nvSpPr>
+          <p:cNvPr id="3" name="Marcador de contenido 2">
+            <a:extLst>
+              <a:ext uri="{FF2B5EF4-FFF2-40B4-BE49-F238E27FC236}">
+                <a16:creationId xmlns:a16="http://schemas.microsoft.com/office/drawing/2014/main" id="{7A85B1BC-912E-98E6-4A17-41BE8990B514}"/>
+              </a:ext>
+            </a:extLst>
+          </p:cNvPr>
+          <p:cNvSpPr>
+            <a:spLocks noGrp="1"/>
+          </p:cNvSpPr>
+          <p:nvPr>
+            <p:ph idx="1"/>
+          </p:nvPr>
+        </p:nvSpPr>
+        <p:spPr/>
+        <p:txBody>
+          <a:bodyPr/>
+          <a:lstStyle/>
+          <a:p>
+            <a:endParaRPr lang="es-EC"/>
+          </a:p>
+        </p:txBody>
+      </p:sp>
+    </p:spTree>
+    <p:extLst>
+      <p:ext uri="{BB962C8B-B14F-4D97-AF65-F5344CB8AC3E}">
+        <p14:creationId xmlns:p14="http://schemas.microsoft.com/office/powerpoint/2010/main" val="108669796"/>
+      </p:ext>
+    </p:extLst>
+  </p:cSld>
+  <p:clrMapOvr>
+    <a:masterClrMapping/>
+  </p:clrMapOvr>
+</p:sld>
+</file>
+
+<file path=ppt/slides/slide7.xml><?xml version="1.0" encoding="utf-8"?>
+<p:sld xmlns:a="http://schemas.openxmlformats.org/drawingml/2006/main" xmlns:r="http://schemas.openxmlformats.org/officeDocument/2006/relationships" xmlns:p="http://schemas.openxmlformats.org/presentationml/2006/main">
+  <p:cSld>
+    <p:spTree>
+      <p:nvGrpSpPr>
+        <p:cNvPr id="1" name=""/>
+        <p:cNvGrpSpPr/>
+        <p:nvPr/>
+      </p:nvGrpSpPr>
+      <p:grpSpPr>
+        <a:xfrm>
+          <a:off x="0" y="0"/>
+          <a:ext cx="0" cy="0"/>
+          <a:chOff x="0" y="0"/>
+          <a:chExt cx="0" cy="0"/>
+        </a:xfrm>
+      </p:grpSpPr>
+      <p:sp>
+        <p:nvSpPr>
+          <p:cNvPr id="2" name="Título 1">
+            <a:extLst>
+              <a:ext uri="{FF2B5EF4-FFF2-40B4-BE49-F238E27FC236}">
+                <a16:creationId xmlns:a16="http://schemas.microsoft.com/office/drawing/2014/main" id="{611C48E9-7F8F-E939-DA83-8E16A963E0B8}"/>
+              </a:ext>
+            </a:extLst>
+          </p:cNvPr>
+          <p:cNvSpPr>
+            <a:spLocks noGrp="1"/>
+          </p:cNvSpPr>
+          <p:nvPr>
+            <p:ph type="title"/>
+          </p:nvPr>
+        </p:nvSpPr>
+        <p:spPr/>
+        <p:txBody>
+          <a:bodyPr/>
+          <a:lstStyle/>
+          <a:p>
+            <a:r>
+              <a:rPr lang="es-ES" dirty="0"/>
+              <a:t>c2</a:t>
+            </a:r>
+            <a:endParaRPr lang="es-EC" dirty="0"/>
+          </a:p>
+        </p:txBody>
+      </p:sp>
+      <p:sp>
+        <p:nvSpPr>
+          <p:cNvPr id="3" name="Marcador de contenido 2">
+            <a:extLst>
+              <a:ext uri="{FF2B5EF4-FFF2-40B4-BE49-F238E27FC236}">
+                <a16:creationId xmlns:a16="http://schemas.microsoft.com/office/drawing/2014/main" id="{F532196F-7557-57DA-3DE3-AF4D471F3B81}"/>
+              </a:ext>
+            </a:extLst>
+          </p:cNvPr>
+          <p:cNvSpPr>
+            <a:spLocks noGrp="1"/>
+          </p:cNvSpPr>
+          <p:nvPr>
+            <p:ph idx="1"/>
+          </p:nvPr>
+        </p:nvSpPr>
+        <p:spPr/>
+        <p:txBody>
+          <a:bodyPr/>
+          <a:lstStyle/>
+          <a:p>
+            <a:endParaRPr lang="es-EC"/>
+          </a:p>
+        </p:txBody>
+      </p:sp>
+    </p:spTree>
+    <p:extLst>
+      <p:ext uri="{BB962C8B-B14F-4D97-AF65-F5344CB8AC3E}">
+        <p14:creationId xmlns:p14="http://schemas.microsoft.com/office/powerpoint/2010/main" val="3052680863"/>
+      </p:ext>
+    </p:extLst>
+  </p:cSld>
+  <p:clrMapOvr>
+    <a:masterClrMapping/>
+  </p:clrMapOvr>
+</p:sld>
+</file>
+
+<file path=ppt/slides/slide8.xml><?xml version="1.0" encoding="utf-8"?>
+<p:sld xmlns:a="http://schemas.openxmlformats.org/drawingml/2006/main" xmlns:r="http://schemas.openxmlformats.org/officeDocument/2006/relationships" xmlns:p="http://schemas.openxmlformats.org/presentationml/2006/main">
+  <p:cSld>
+    <p:spTree>
+      <p:nvGrpSpPr>
+        <p:cNvPr id="1" name=""/>
+        <p:cNvGrpSpPr/>
+        <p:nvPr/>
+      </p:nvGrpSpPr>
+      <p:grpSpPr>
+        <a:xfrm>
+          <a:off x="0" y="0"/>
+          <a:ext cx="0" cy="0"/>
+          <a:chOff x="0" y="0"/>
+          <a:chExt cx="0" cy="0"/>
+        </a:xfrm>
+      </p:grpSpPr>
+      <p:sp>
+        <p:nvSpPr>
+          <p:cNvPr id="2" name="Título 1">
+            <a:extLst>
+              <a:ext uri="{FF2B5EF4-FFF2-40B4-BE49-F238E27FC236}">
+                <a16:creationId xmlns:a16="http://schemas.microsoft.com/office/drawing/2014/main" id="{6B393A51-0E9D-0708-2D03-D6E66AF8578F}"/>
+              </a:ext>
+            </a:extLst>
+          </p:cNvPr>
+          <p:cNvSpPr>
+            <a:spLocks noGrp="1"/>
+          </p:cNvSpPr>
+          <p:nvPr>
+            <p:ph type="title"/>
+          </p:nvPr>
+        </p:nvSpPr>
+        <p:spPr/>
+        <p:txBody>
+          <a:bodyPr/>
+          <a:lstStyle/>
+          <a:p>
+            <a:r>
+              <a:rPr lang="es-ES"/>
+              <a:t>c3</a:t>
+            </a:r>
+            <a:endParaRPr lang="es-EC"/>
+          </a:p>
+        </p:txBody>
+      </p:sp>
+      <p:sp>
+        <p:nvSpPr>
+          <p:cNvPr id="3" name="Marcador de contenido 2">
+            <a:extLst>
+              <a:ext uri="{FF2B5EF4-FFF2-40B4-BE49-F238E27FC236}">
+                <a16:creationId xmlns:a16="http://schemas.microsoft.com/office/drawing/2014/main" id="{3E3B11AB-AF2B-92C2-554C-7C0D2E727224}"/>
+              </a:ext>
+            </a:extLst>
+          </p:cNvPr>
+          <p:cNvSpPr>
+            <a:spLocks noGrp="1"/>
+          </p:cNvSpPr>
+          <p:nvPr>
+            <p:ph idx="1"/>
+          </p:nvPr>
+        </p:nvSpPr>
+        <p:spPr/>
+        <p:txBody>
+          <a:bodyPr/>
+          <a:lstStyle/>
+          <a:p>
+            <a:endParaRPr lang="es-EC"/>
+          </a:p>
+        </p:txBody>
+      </p:sp>
+    </p:spTree>
+    <p:extLst>
+      <p:ext uri="{BB962C8B-B14F-4D97-AF65-F5344CB8AC3E}">
+        <p14:creationId xmlns:p14="http://schemas.microsoft.com/office/powerpoint/2010/main" val="1552665504"/>
+      </p:ext>
+    </p:extLst>
+  </p:cSld>
+  <p:clrMapOvr>
+    <a:masterClrMapping/>
+  </p:clrMapOvr>
+</p:sld>
+</file>
+
 <file path=ppt/theme/theme1.xml><?xml version="1.0" encoding="utf-8"?>
 <a:theme xmlns:a="http://schemas.openxmlformats.org/drawingml/2006/main" name="Tema de Office">
   <a:themeElements>

</xml_diff>